<commit_message>
Cut programme to 65 items, fix teaching fit, tick checklist, update deck
Co-Authored-By: Claude Sonnet 5.5 <noreply@anthropic.com>
</commit_message>
<xml_diff>
--- a/presentation.pptx
+++ b/presentation.pptx
@@ -1971,7 +1971,7 @@
                 <a:ea typeface="Calibri" pitchFamily="34" charset="-122"/>
                 <a:cs typeface="Calibri" pitchFamily="34" charset="-120"/>
               </a:rPr>
-              <a:t>Since Seminar 1: concept locked, specification written, data built (64 performers, 72 programme items) and validated.</a:t>
+              <a:t>Since Seminar 1: concept locked, specification written, data built (64 performers, 65 programme items) and validated.</a:t>
             </a:r>
             <a:endParaRPr lang="en-US" sz="1800" dirty="0"/>
           </a:p>
@@ -5461,7 +5461,7 @@
                 <a:ea typeface="Calibri" pitchFamily="34" charset="-122"/>
                 <a:cs typeface="Calibri" pitchFamily="34" charset="-120"/>
               </a:rPr>
-              <a:t>Drafted the spec and the data schema. Generated 64 performers and 72 programme items. Wrote the validator and converter scripts. Researched names and a reference site.</a:t>
+              <a:t>Drafted the spec and the data schema. Generated 64 performers and 65 programme items. Wrote the validator and converter scripts. Researched names and a reference site.</a:t>
             </a:r>
             <a:endParaRPr lang="en-US" sz="1700" dirty="0"/>
           </a:p>
@@ -5583,7 +5583,7 @@
                 <a:ea typeface="Calibri" pitchFamily="34" charset="-122"/>
                 <a:cs typeface="Calibri" pitchFamily="34" charset="-120"/>
               </a:rPr>
-              <a:t>A script checks ids, overlaps, double-booked performers, dates and sensible times. Its 9 errors showed our schema had no rule for sets after midnight, so we added a 06:00 to 06:00 programme day. We also read 10 random records by hand.</a:t>
+              <a:t>A script checks ids, overlaps, double-booked performers, dates and sensible times. Its 9 errors showed our schema had no rule for sets after midnight, so we added a 06:00 to 06:00 programme day. Reading 10 records by hand caught a teacher mismatch the script cannot see.</a:t>
             </a:r>
             <a:endParaRPr lang="en-US" sz="1700" dirty="0"/>
           </a:p>

</xml_diff>

<commit_message>
Rename festival to Atardecer Bachata Festival
Co-Authored-By: Claude Sonnet 5.5 <noreply@anthropic.com>
</commit_message>
<xml_diff>
--- a/presentation.pptx
+++ b/presentation.pptx
@@ -508,7 +508,7 @@
               <a:rPr lang="en-US" dirty="0"/>
               <a:t>PRESENTER: Faiaz (about 50 seconds).
 Say: what the festival is, why Valencia, what the website is for, and the main decisions since Seminar 1.
-Key points: 3 days, 25-27 June 2027. Sea by day, club by night. We renamed after finding the real festival RAICES. Our reason for Valencia: clean, modern city with sea access, so outdoor dancing by the sea and indoor dancing at night.</a:t>
+Key points: 3 days, 25-27 June 2027. Sea by day, club by night. We renamed twice: after finding the real festival RAICES, and after Sebastian found a similar name. The final name is Atardecer, Spanish for sunset. Our reason for Valencia: clean, modern city with sea access, so outdoor dancing by the sea and indoor dancing at night.</a:t>
             </a:r>
             <a:endParaRPr lang="en-US" dirty="0"/>
           </a:p>
@@ -993,7 +993,7 @@
                 <a:ea typeface="Calibri" pitchFamily="34" charset="-122"/>
                 <a:cs typeface="Calibri" pitchFamily="34" charset="-120"/>
               </a:rPr>
-              <a:t>Latino Mar Bachata Festival · Seminar 2</a:t>
+              <a:t>Atardecer Bachata Festival · Seminar 2</a:t>
             </a:r>
             <a:endParaRPr lang="en-US" sz="1200" dirty="0"/>
           </a:p>
@@ -1154,7 +1154,7 @@
                 <a:ea typeface="Calibri" pitchFamily="34" charset="-122"/>
                 <a:cs typeface="Calibri" pitchFamily="34" charset="-120"/>
               </a:rPr>
-              <a:t>Latino Mar Bachata Festival · Seminar 2</a:t>
+              <a:t>Atardecer Bachata Festival · Seminar 2</a:t>
             </a:r>
             <a:endParaRPr lang="en-US" sz="1200" dirty="0"/>
           </a:p>
@@ -1593,7 +1593,7 @@
                 <a:ea typeface="Cambria" pitchFamily="34" charset="-122"/>
                 <a:cs typeface="Cambria" pitchFamily="34" charset="-120"/>
               </a:rPr>
-              <a:t>Latino Mar Bachata Festival</a:t>
+              <a:t>Atardecer Bachata Festival</a:t>
             </a:r>
             <a:endParaRPr lang="en-US" sz="4400" dirty="0"/>
           </a:p>
@@ -1932,7 +1932,7 @@
                 <a:ea typeface="Calibri" pitchFamily="34" charset="-122"/>
                 <a:cs typeface="Calibri" pitchFamily="34" charset="-120"/>
               </a:rPr>
-              <a:t>Renamed the festival after a real one, RAICES, used the same word. Cut to 3 days. Added a Roots page on bachata dominicana. Dropped volunteers, partners and talks.</a:t>
+              <a:t>Renamed twice: first after RAICES, then after a similar name Sebastian found. Cut to 3 days and 65 items. Added a Roots page. Dropped volunteers, partners and talks.</a:t>
             </a:r>
             <a:endParaRPr lang="en-US" sz="1800" dirty="0"/>
           </a:p>
@@ -5521,7 +5521,7 @@
                 <a:ea typeface="Calibri" pitchFamily="34" charset="-122"/>
                 <a:cs typeface="Calibri" pitchFamily="34" charset="-120"/>
               </a:rPr>
-              <a:t>We chose the concept and the name. We rejected “Raíces del Mar” (real festival RAICES), a 4-day format and three extra features.</a:t>
+              <a:t>We chose the concept and the name. We rejected two names (a clash with RAICES, then a similar name), a 4-day format and three extra features.</a:t>
             </a:r>
             <a:endParaRPr lang="en-US" sz="1700" dirty="0"/>
           </a:p>
@@ -5706,9 +5706,9 @@
 </file>
 
 <file path=ppt/theme/theme1.xml><?xml version="1.0" encoding="utf-8"?>
-<a:theme xmlns:a="http://schemas.openxmlformats.org/drawingml/2006/main" name="Latino Mar">
+<a:theme xmlns:a="http://schemas.openxmlformats.org/drawingml/2006/main" name="Atardecer">
   <a:themeElements>
-    <a:clrScheme name="Latino Mar">
+    <a:clrScheme name="Atardecer">
       <a:dk1>
         <a:srgbClr val="10202E"/>
       </a:dk1>
@@ -5746,7 +5746,7 @@
         <a:srgbClr val="4A5A66"/>
       </a:folHlink>
     </a:clrScheme>
-    <a:fontScheme name="Latino Mar">
+    <a:fontScheme name="Atardecer">
       <a:majorFont>
         <a:latin typeface="Cambria"/>
         <a:ea typeface=""/>

</xml_diff>

<commit_message>
Merge practical pages: sitemap from 17 to 12 pages
Co-Authored-By: Claude Sonnet 5.5 <noreply@anthropic.com>
</commit_message>
<xml_diff>
--- a/presentation.pptx
+++ b/presentation.pptx
@@ -686,7 +686,7 @@
             <a:r>
               <a:rPr lang="en-US" dirty="0"/>
               <a:t>PRESENTER: Oscar (about 50 seconds).
-Say: home page, six main sections in the navigation, detail pages for sessions, performers and venues, six practical pages, search on every page with a results page. Mention breadcrumbs, and that detail pages are one template filled from the data (no build step).</a:t>
+Say: home page, six main sections in the navigation, detail pages for sessions, performers and venues, one Practical info page with five sections, search on every page with a results page. Mention breadcrumbs, and that detail pages are one template filled from the data (no build step).</a:t>
             </a:r>
             <a:endParaRPr lang="en-US" dirty="0"/>
           </a:p>
@@ -2969,7 +2969,7 @@
                 <a:ea typeface="Calibri" pitchFamily="34" charset="-122"/>
                 <a:cs typeface="Calibri" pitchFamily="34" charset="-120"/>
               </a:rPr>
-              <a:t>Accessibility page, venue pages, FAQ, group tickets.</a:t>
+              <a:t>Accessibility section, venue pages, FAQ, group tickets.</a:t>
             </a:r>
             <a:endParaRPr lang="en-US" sz="1600" dirty="0"/>
           </a:p>
@@ -3083,7 +3083,7 @@
                 <a:ea typeface="Cambria" pitchFamily="34" charset="-122"/>
                 <a:cs typeface="Cambria" pitchFamily="34" charset="-120"/>
               </a:rPr>
-              <a:t>Information architecture: 17 pages</a:t>
+              <a:t>Information architecture: 12 pages</a:t>
             </a:r>
             <a:endParaRPr lang="en-US" sz="3600" dirty="0"/>
           </a:p>
@@ -4092,18 +4092,18 @@
       </p:sp>
       <p:sp>
         <p:nvSpPr>
-          <p:cNvPr id="38" name="Practical pages"/>
+          <p:cNvPr id="38" name="Box Tickets"/>
           <p:cNvSpPr/>
           <p:nvPr/>
         </p:nvSpPr>
         <p:spPr>
           <a:xfrm>
             <a:off x="8061808" y="3520440"/>
-            <a:ext cx="1691640" cy="2011680"/>
+            <a:ext cx="1691640" cy="640080"/>
           </a:xfrm>
           <a:prstGeom prst="roundRect">
             <a:avLst>
-              <a:gd name="adj" fmla="val 4324"/>
+              <a:gd name="adj" fmla="val 11429"/>
             </a:avLst>
           </a:prstGeom>
           <a:solidFill>
@@ -4126,7 +4126,7 @@
         <p:spPr>
           <a:xfrm>
             <a:off x="8061808" y="3520440"/>
-            <a:ext cx="1691640" cy="2011680"/>
+            <a:ext cx="1691640" cy="640080"/>
           </a:xfrm>
           <a:prstGeom prst="rect">
             <a:avLst/>
@@ -4142,6 +4142,67 @@
               <a:buNone/>
             </a:pPr>
             <a:r>
+              <a:rPr lang="en-US" sz="1500" b="1" dirty="0">
+                <a:solidFill>
+                  <a:srgbClr val="0B1B2B"/>
+                </a:solidFill>
+                <a:latin typeface="Calibri" pitchFamily="34" charset="0"/>
+                <a:ea typeface="Calibri" pitchFamily="34" charset="-122"/>
+                <a:cs typeface="Calibri" pitchFamily="34" charset="-120"/>
+              </a:rPr>
+              <a:t>Tickets</a:t>
+            </a:r>
+            <a:endParaRPr lang="en-US" sz="1500" dirty="0"/>
+          </a:p>
+        </p:txBody>
+      </p:sp>
+      <p:sp>
+        <p:nvSpPr>
+          <p:cNvPr id="40" name="Practical sections"/>
+          <p:cNvSpPr/>
+          <p:nvPr/>
+        </p:nvSpPr>
+        <p:spPr>
+          <a:xfrm>
+            <a:off x="8061808" y="4297680"/>
+            <a:ext cx="1691640" cy="1325880"/>
+          </a:xfrm>
+          <a:prstGeom prst="roundRect">
+            <a:avLst>
+              <a:gd name="adj" fmla="val 5517"/>
+            </a:avLst>
+          </a:prstGeom>
+          <a:solidFill>
+            <a:srgbClr val="EAF4F5"/>
+          </a:solidFill>
+          <a:ln/>
+        </p:spPr>
+      </p:sp>
+      <p:sp>
+        <p:nvSpPr>
+          <p:cNvPr id="41" name="Text 39"/>
+          <p:cNvSpPr txBox="1"/>
+          <p:nvPr/>
+        </p:nvSpPr>
+        <p:spPr>
+          <a:xfrm>
+            <a:off x="8061808" y="4297680"/>
+            <a:ext cx="1691640" cy="1325880"/>
+          </a:xfrm>
+          <a:prstGeom prst="rect">
+            <a:avLst/>
+          </a:prstGeom>
+          <a:noFill/>
+          <a:ln/>
+        </p:spPr>
+        <p:txBody>
+          <a:bodyPr wrap="square" lIns="0" tIns="0" rIns="0" bIns="0" rtlCol="0" anchor="ctr"/>
+          <a:lstStyle/>
+          <a:p>
+            <a:pPr algn="ctr" indent="0" marL="0">
+              <a:buNone/>
+            </a:pPr>
+            <a:r>
               <a:rPr lang="en-US" sz="1400" dirty="0">
                 <a:solidFill>
                   <a:srgbClr val="0B1B2B"/>
@@ -4150,7 +4211,7 @@
                 <a:ea typeface="Calibri" pitchFamily="34" charset="-122"/>
                 <a:cs typeface="Calibri" pitchFamily="34" charset="-120"/>
               </a:rPr>
-              <a:t>Tickets</a:t>
+              <a:t>Travel</a:t>
             </a:r>
             <a:endParaRPr lang="en-US" sz="1400" dirty="0"/>
           </a:p>
@@ -4167,7 +4228,7 @@
                 <a:ea typeface="Calibri" pitchFamily="34" charset="-122"/>
                 <a:cs typeface="Calibri" pitchFamily="34" charset="-120"/>
               </a:rPr>
-              <a:t>Travel</a:t>
+              <a:t>Accommodation</a:t>
             </a:r>
             <a:endParaRPr lang="en-US" sz="1400" dirty="0"/>
           </a:p>
@@ -4184,7 +4245,7 @@
                 <a:ea typeface="Calibri" pitchFamily="34" charset="-122"/>
                 <a:cs typeface="Calibri" pitchFamily="34" charset="-120"/>
               </a:rPr>
-              <a:t>Accommodation</a:t>
+              <a:t>Accessibility</a:t>
             </a:r>
             <a:endParaRPr lang="en-US" sz="1400" dirty="0"/>
           </a:p>
@@ -4201,7 +4262,7 @@
                 <a:ea typeface="Calibri" pitchFamily="34" charset="-122"/>
                 <a:cs typeface="Calibri" pitchFamily="34" charset="-120"/>
               </a:rPr>
-              <a:t>Accessibility</a:t>
+              <a:t>FAQ</a:t>
             </a:r>
             <a:endParaRPr lang="en-US" sz="1400" dirty="0"/>
           </a:p>
@@ -4218,39 +4279,22 @@
                 <a:ea typeface="Calibri" pitchFamily="34" charset="-122"/>
                 <a:cs typeface="Calibri" pitchFamily="34" charset="-120"/>
               </a:rPr>
-              <a:t>FAQ</a:t>
+              <a:t>Code of conduct</a:t>
             </a:r>
             <a:endParaRPr lang="en-US" sz="1400" dirty="0"/>
           </a:p>
-          <a:p>
-            <a:pPr algn="ctr" indent="0" marL="0">
-              <a:buNone/>
-            </a:pPr>
-            <a:r>
-              <a:rPr lang="en-US" sz="1400" dirty="0">
-                <a:solidFill>
-                  <a:srgbClr val="0B1B2B"/>
-                </a:solidFill>
-                <a:latin typeface="Calibri" pitchFamily="34" charset="0"/>
-                <a:ea typeface="Calibri" pitchFamily="34" charset="-122"/>
-                <a:cs typeface="Calibri" pitchFamily="34" charset="-120"/>
-              </a:rPr>
-              <a:t>Code of conduct</a:t>
-            </a:r>
-            <a:endParaRPr lang="en-US" sz="1400" dirty="0"/>
-          </a:p>
-        </p:txBody>
-      </p:sp>
-      <p:sp>
-        <p:nvSpPr>
-          <p:cNvPr id="40" name="Relationships"/>
+        </p:txBody>
+      </p:sp>
+      <p:sp>
+        <p:nvSpPr>
+          <p:cNvPr id="42" name="Relationships"/>
           <p:cNvSpPr txBox="1"/>
           <p:nvPr/>
         </p:nvSpPr>
         <p:spPr>
           <a:xfrm>
-            <a:off x="548640" y="5669280"/>
-            <a:ext cx="11064240" cy="594360"/>
+            <a:off x="548640" y="5806440"/>
+            <a:ext cx="11064240" cy="548640"/>
           </a:xfrm>
           <a:prstGeom prst="rect">
             <a:avLst/>
@@ -4274,7 +4318,7 @@
                 <a:ea typeface="Calibri" pitchFamily="34" charset="-122"/>
                 <a:cs typeface="Calibri" pitchFamily="34" charset="-120"/>
               </a:rPr>
-              <a:t>Links between sections: a session lists its performers and its venue, and each of those pages lists its sessions. Every session has a Save button that feeds My Programme. Breadcrumbs on every inner page.</a:t>
+              <a:t>Links between sections: a session lists its performers and its venue, and each of those pages lists its sessions. Every session has a Save button that feeds My Programme. Practical info is one page with five sections. Breadcrumbs on every inner page.</a:t>
             </a:r>
             <a:endParaRPr lang="en-US" sz="1500" dirty="0"/>
           </a:p>

</xml_diff>